<commit_message>
hat most ezt inteztem
</commit_message>
<xml_diff>
--- a/Dokumentáció/StockMaster_Prezentacio.pptx
+++ b/Dokumentáció/StockMaster_Prezentacio.pptx
@@ -209,7 +209,7 @@
           <a:p>
             <a:fld id="{DBB7823A-862C-422A-A575-936A9871EC5A}" type="datetimeFigureOut">
               <a:rPr lang="hu-HU" smtClean="0"/>
-              <a:t>2026. 03. 24.</a:t>
+              <a:t>2026. 03. 27.</a:t>
             </a:fld>
             <a:endParaRPr lang="hu-HU"/>
           </a:p>
@@ -1937,7 +1937,7 @@
           <a:p>
             <a:fld id="{D31F9038-47AD-43A3-BBBF-D66692911134}" type="datetimeFigureOut">
               <a:rPr lang="hu-HU" smtClean="0"/>
-              <a:t>2026. 03. 24.</a:t>
+              <a:t>2026. 03. 27.</a:t>
             </a:fld>
             <a:endParaRPr lang="hu-HU"/>
           </a:p>
@@ -2135,7 +2135,7 @@
           <a:p>
             <a:fld id="{D31F9038-47AD-43A3-BBBF-D66692911134}" type="datetimeFigureOut">
               <a:rPr lang="hu-HU" smtClean="0"/>
-              <a:t>2026. 03. 24.</a:t>
+              <a:t>2026. 03. 27.</a:t>
             </a:fld>
             <a:endParaRPr lang="hu-HU"/>
           </a:p>
@@ -2343,7 +2343,7 @@
           <a:p>
             <a:fld id="{D31F9038-47AD-43A3-BBBF-D66692911134}" type="datetimeFigureOut">
               <a:rPr lang="hu-HU" smtClean="0"/>
-              <a:t>2026. 03. 24.</a:t>
+              <a:t>2026. 03. 27.</a:t>
             </a:fld>
             <a:endParaRPr lang="hu-HU"/>
           </a:p>
@@ -2541,7 +2541,7 @@
           <a:p>
             <a:fld id="{D31F9038-47AD-43A3-BBBF-D66692911134}" type="datetimeFigureOut">
               <a:rPr lang="hu-HU" smtClean="0"/>
-              <a:t>2026. 03. 24.</a:t>
+              <a:t>2026. 03. 27.</a:t>
             </a:fld>
             <a:endParaRPr lang="hu-HU"/>
           </a:p>
@@ -2816,7 +2816,7 @@
           <a:p>
             <a:fld id="{D31F9038-47AD-43A3-BBBF-D66692911134}" type="datetimeFigureOut">
               <a:rPr lang="hu-HU" smtClean="0"/>
-              <a:t>2026. 03. 24.</a:t>
+              <a:t>2026. 03. 27.</a:t>
             </a:fld>
             <a:endParaRPr lang="hu-HU"/>
           </a:p>
@@ -3081,7 +3081,7 @@
           <a:p>
             <a:fld id="{D31F9038-47AD-43A3-BBBF-D66692911134}" type="datetimeFigureOut">
               <a:rPr lang="hu-HU" smtClean="0"/>
-              <a:t>2026. 03. 24.</a:t>
+              <a:t>2026. 03. 27.</a:t>
             </a:fld>
             <a:endParaRPr lang="hu-HU"/>
           </a:p>
@@ -3493,7 +3493,7 @@
           <a:p>
             <a:fld id="{D31F9038-47AD-43A3-BBBF-D66692911134}" type="datetimeFigureOut">
               <a:rPr lang="hu-HU" smtClean="0"/>
-              <a:t>2026. 03. 24.</a:t>
+              <a:t>2026. 03. 27.</a:t>
             </a:fld>
             <a:endParaRPr lang="hu-HU"/>
           </a:p>
@@ -3634,7 +3634,7 @@
           <a:p>
             <a:fld id="{D31F9038-47AD-43A3-BBBF-D66692911134}" type="datetimeFigureOut">
               <a:rPr lang="hu-HU" smtClean="0"/>
-              <a:t>2026. 03. 24.</a:t>
+              <a:t>2026. 03. 27.</a:t>
             </a:fld>
             <a:endParaRPr lang="hu-HU"/>
           </a:p>
@@ -3747,7 +3747,7 @@
           <a:p>
             <a:fld id="{D31F9038-47AD-43A3-BBBF-D66692911134}" type="datetimeFigureOut">
               <a:rPr lang="hu-HU" smtClean="0"/>
-              <a:t>2026. 03. 24.</a:t>
+              <a:t>2026. 03. 27.</a:t>
             </a:fld>
             <a:endParaRPr lang="hu-HU"/>
           </a:p>
@@ -4058,7 +4058,7 @@
           <a:p>
             <a:fld id="{D31F9038-47AD-43A3-BBBF-D66692911134}" type="datetimeFigureOut">
               <a:rPr lang="hu-HU" smtClean="0"/>
-              <a:t>2026. 03. 24.</a:t>
+              <a:t>2026. 03. 27.</a:t>
             </a:fld>
             <a:endParaRPr lang="hu-HU"/>
           </a:p>
@@ -4346,7 +4346,7 @@
           <a:p>
             <a:fld id="{D31F9038-47AD-43A3-BBBF-D66692911134}" type="datetimeFigureOut">
               <a:rPr lang="hu-HU" smtClean="0"/>
-              <a:t>2026. 03. 24.</a:t>
+              <a:t>2026. 03. 27.</a:t>
             </a:fld>
             <a:endParaRPr lang="hu-HU"/>
           </a:p>
@@ -4587,7 +4587,7 @@
           <a:p>
             <a:fld id="{D31F9038-47AD-43A3-BBBF-D66692911134}" type="datetimeFigureOut">
               <a:rPr lang="hu-HU" smtClean="0"/>
-              <a:t>2026. 03. 24.</a:t>
+              <a:t>2026. 03. 27.</a:t>
             </a:fld>
             <a:endParaRPr lang="hu-HU"/>
           </a:p>

</xml_diff>